<commit_message>
fix: harden provider identity and credential binding
Co-authored-by: Codex <codex@openai.com>
</commit_message>
<xml_diff>
--- a/assets/COFORGE-Company-Pitch.pptx
+++ b/assets/COFORGE-Company-Pitch.pptx
@@ -2,22 +2,22 @@
 <file path=ppt/presentation.xml><?xml version="1.0" encoding="utf-8"?>
 <p:presentation xmlns:p="http://schemas.openxmlformats.org/presentationml/2006/main">
   <p:sldMasterIdLst>
-    <p:sldMasterId xmlns:r="http://schemas.openxmlformats.org/officeDocument/2006/relationships" id="2147483648" r:id="R41031b9b57004dfd"/>
+    <p:sldMasterId xmlns:r="http://schemas.openxmlformats.org/officeDocument/2006/relationships" id="2147483648" r:id="R2f7858c5e684447b"/>
   </p:sldMasterIdLst>
   <p:notesMasterIdLst>
-    <p:notesMasterId xmlns:r="http://schemas.openxmlformats.org/officeDocument/2006/relationships" r:id="R269f461e380b4c40"/>
+    <p:notesMasterId xmlns:r="http://schemas.openxmlformats.org/officeDocument/2006/relationships" r:id="R278cccd6f10f4eb5"/>
   </p:notesMasterIdLst>
   <p:sldIdLst>
-    <p:sldId xmlns:r="http://schemas.openxmlformats.org/officeDocument/2006/relationships" id="256" r:id="Rdd1092bfaa124ac0"/>
-    <p:sldId xmlns:r="http://schemas.openxmlformats.org/officeDocument/2006/relationships" id="257" r:id="R7ec3bb8723cd4a9c"/>
-    <p:sldId xmlns:r="http://schemas.openxmlformats.org/officeDocument/2006/relationships" id="258" r:id="R95cbfb14d6214074"/>
-    <p:sldId xmlns:r="http://schemas.openxmlformats.org/officeDocument/2006/relationships" id="259" r:id="Re56e6bd888d34c1d"/>
-    <p:sldId xmlns:r="http://schemas.openxmlformats.org/officeDocument/2006/relationships" id="260" r:id="R16ad16dc2f554a35"/>
-    <p:sldId xmlns:r="http://schemas.openxmlformats.org/officeDocument/2006/relationships" id="261" r:id="R98098d96186b41bd"/>
-    <p:sldId xmlns:r="http://schemas.openxmlformats.org/officeDocument/2006/relationships" id="262" r:id="Rbf7ffd48bafc4fd8"/>
-    <p:sldId xmlns:r="http://schemas.openxmlformats.org/officeDocument/2006/relationships" id="263" r:id="R1c955a9599574d87"/>
-    <p:sldId xmlns:r="http://schemas.openxmlformats.org/officeDocument/2006/relationships" id="264" r:id="R9f83bac648ec4178"/>
-    <p:sldId xmlns:r="http://schemas.openxmlformats.org/officeDocument/2006/relationships" id="265" r:id="R39fdf237ed2e4fde"/>
+    <p:sldId xmlns:r="http://schemas.openxmlformats.org/officeDocument/2006/relationships" id="256" r:id="R5da8308b95604760"/>
+    <p:sldId xmlns:r="http://schemas.openxmlformats.org/officeDocument/2006/relationships" id="257" r:id="R4f128548ddff416c"/>
+    <p:sldId xmlns:r="http://schemas.openxmlformats.org/officeDocument/2006/relationships" id="258" r:id="R74b07ed7845f4d51"/>
+    <p:sldId xmlns:r="http://schemas.openxmlformats.org/officeDocument/2006/relationships" id="259" r:id="R5b322bb67d67489b"/>
+    <p:sldId xmlns:r="http://schemas.openxmlformats.org/officeDocument/2006/relationships" id="260" r:id="R4ab7c939d33c4cb6"/>
+    <p:sldId xmlns:r="http://schemas.openxmlformats.org/officeDocument/2006/relationships" id="261" r:id="Rc9bfac6e444e44b6"/>
+    <p:sldId xmlns:r="http://schemas.openxmlformats.org/officeDocument/2006/relationships" id="262" r:id="R2a4a8449f38343b8"/>
+    <p:sldId xmlns:r="http://schemas.openxmlformats.org/officeDocument/2006/relationships" id="263" r:id="Rff202cc9a1014ddf"/>
+    <p:sldId xmlns:r="http://schemas.openxmlformats.org/officeDocument/2006/relationships" id="264" r:id="R6bdd48686434491b"/>
+    <p:sldId xmlns:r="http://schemas.openxmlformats.org/officeDocument/2006/relationships" id="265" r:id="R4379a021d0914bfa"/>
   </p:sldIdLst>
   <p:sldSz cx="12192000" cy="6858000"/>
   <p:notesSz cx="6858000" cy="9144000"/>
@@ -1158,7 +1158,7 @@
   </p:cSld>
   <p:clrMap bg1="lt1" tx1="dk1" bg2="lt2" tx2="dk2" accent1="accent1" accent2="accent2" accent3="accent3" accent4="accent4" accent5="accent5" accent6="accent6" hlink="hlink" folHlink="folHlink"/>
   <p:sldLayoutIdLst>
-    <p:sldLayoutId xmlns:r="http://schemas.openxmlformats.org/officeDocument/2006/relationships" id="2147483649" r:id="R68cf6bcfae0749f9"/>
+    <p:sldLayoutId xmlns:r="http://schemas.openxmlformats.org/officeDocument/2006/relationships" id="2147483649" r:id="Rada2854ff7dc46d6"/>
   </p:sldLayoutIdLst>
   <p:txStyles>
     <p:titleStyle>
@@ -5870,7 +5870,7 @@
               </a:defRPr>
             </a:pPr>
             <a:r>
-              <a:t>255</a:t>
+              <a:t>257</a:t>
             </a:r>
           </a:p>
         </p:txBody>

</xml_diff>

<commit_message>
fix: bind provider settings to Keychain transactions
Co-authored-by: Codex <codex@openai.com>
</commit_message>
<xml_diff>
--- a/assets/COFORGE-Company-Pitch.pptx
+++ b/assets/COFORGE-Company-Pitch.pptx
@@ -2,22 +2,22 @@
 <file path=ppt/presentation.xml><?xml version="1.0" encoding="utf-8"?>
 <p:presentation xmlns:p="http://schemas.openxmlformats.org/presentationml/2006/main">
   <p:sldMasterIdLst>
-    <p:sldMasterId xmlns:r="http://schemas.openxmlformats.org/officeDocument/2006/relationships" id="2147483648" r:id="R2f7858c5e684447b"/>
+    <p:sldMasterId xmlns:r="http://schemas.openxmlformats.org/officeDocument/2006/relationships" id="2147483648" r:id="R3ecbcb8cba8e423a"/>
   </p:sldMasterIdLst>
   <p:notesMasterIdLst>
-    <p:notesMasterId xmlns:r="http://schemas.openxmlformats.org/officeDocument/2006/relationships" r:id="R278cccd6f10f4eb5"/>
+    <p:notesMasterId xmlns:r="http://schemas.openxmlformats.org/officeDocument/2006/relationships" r:id="R873936a5d26d4418"/>
   </p:notesMasterIdLst>
   <p:sldIdLst>
-    <p:sldId xmlns:r="http://schemas.openxmlformats.org/officeDocument/2006/relationships" id="256" r:id="R5da8308b95604760"/>
-    <p:sldId xmlns:r="http://schemas.openxmlformats.org/officeDocument/2006/relationships" id="257" r:id="R4f128548ddff416c"/>
-    <p:sldId xmlns:r="http://schemas.openxmlformats.org/officeDocument/2006/relationships" id="258" r:id="R74b07ed7845f4d51"/>
-    <p:sldId xmlns:r="http://schemas.openxmlformats.org/officeDocument/2006/relationships" id="259" r:id="R5b322bb67d67489b"/>
-    <p:sldId xmlns:r="http://schemas.openxmlformats.org/officeDocument/2006/relationships" id="260" r:id="R4ab7c939d33c4cb6"/>
-    <p:sldId xmlns:r="http://schemas.openxmlformats.org/officeDocument/2006/relationships" id="261" r:id="Rc9bfac6e444e44b6"/>
-    <p:sldId xmlns:r="http://schemas.openxmlformats.org/officeDocument/2006/relationships" id="262" r:id="R2a4a8449f38343b8"/>
-    <p:sldId xmlns:r="http://schemas.openxmlformats.org/officeDocument/2006/relationships" id="263" r:id="Rff202cc9a1014ddf"/>
-    <p:sldId xmlns:r="http://schemas.openxmlformats.org/officeDocument/2006/relationships" id="264" r:id="R6bdd48686434491b"/>
-    <p:sldId xmlns:r="http://schemas.openxmlformats.org/officeDocument/2006/relationships" id="265" r:id="R4379a021d0914bfa"/>
+    <p:sldId xmlns:r="http://schemas.openxmlformats.org/officeDocument/2006/relationships" id="256" r:id="R5b53d96ae49544b9"/>
+    <p:sldId xmlns:r="http://schemas.openxmlformats.org/officeDocument/2006/relationships" id="257" r:id="R100aa7435bc14edd"/>
+    <p:sldId xmlns:r="http://schemas.openxmlformats.org/officeDocument/2006/relationships" id="258" r:id="R4d14743308484e2c"/>
+    <p:sldId xmlns:r="http://schemas.openxmlformats.org/officeDocument/2006/relationships" id="259" r:id="R84df0c95e2ad42da"/>
+    <p:sldId xmlns:r="http://schemas.openxmlformats.org/officeDocument/2006/relationships" id="260" r:id="R0d1a69e9f554406e"/>
+    <p:sldId xmlns:r="http://schemas.openxmlformats.org/officeDocument/2006/relationships" id="261" r:id="Rfeacc05d031b4781"/>
+    <p:sldId xmlns:r="http://schemas.openxmlformats.org/officeDocument/2006/relationships" id="262" r:id="R24ea54b53f3d4105"/>
+    <p:sldId xmlns:r="http://schemas.openxmlformats.org/officeDocument/2006/relationships" id="263" r:id="R5bff929d28e04aed"/>
+    <p:sldId xmlns:r="http://schemas.openxmlformats.org/officeDocument/2006/relationships" id="264" r:id="R9a4c214152e04f61"/>
+    <p:sldId xmlns:r="http://schemas.openxmlformats.org/officeDocument/2006/relationships" id="265" r:id="R57f20f21529e48ff"/>
   </p:sldIdLst>
   <p:sldSz cx="12192000" cy="6858000"/>
   <p:notesSz cx="6858000" cy="9144000"/>
@@ -1158,7 +1158,7 @@
   </p:cSld>
   <p:clrMap bg1="lt1" tx1="dk1" bg2="lt2" tx2="dk2" accent1="accent1" accent2="accent2" accent3="accent3" accent4="accent4" accent5="accent5" accent6="accent6" hlink="hlink" folHlink="folHlink"/>
   <p:sldLayoutIdLst>
-    <p:sldLayoutId xmlns:r="http://schemas.openxmlformats.org/officeDocument/2006/relationships" id="2147483649" r:id="Rada2854ff7dc46d6"/>
+    <p:sldLayoutId xmlns:r="http://schemas.openxmlformats.org/officeDocument/2006/relationships" id="2147483649" r:id="Rf6f88b21c861414c"/>
   </p:sldLayoutIdLst>
   <p:txStyles>
     <p:titleStyle>
@@ -5870,7 +5870,7 @@
               </a:defRPr>
             </a:pPr>
             <a:r>
-              <a:t>257</a:t>
+              <a:t>258</a:t>
             </a:r>
           </a:p>
         </p:txBody>

</xml_diff>